<commit_message>
Record fresh Thor live validation and update review deck
</commit_message>
<xml_diff>
--- a/docs/OmTrackVLA Ridgeback technical review 2026-09-28.pptx
+++ b/docs/OmTrackVLA Ridgeback technical review 2026-09-28.pptx
@@ -2,31 +2,31 @@
 <file path=ppt/presentation.xml><?xml version="1.0" encoding="utf-8"?>
 <p:presentation xmlns:p="http://schemas.openxmlformats.org/presentationml/2006/main">
   <p:sldMasterIdLst>
-    <p:sldMasterId xmlns:r="http://schemas.openxmlformats.org/officeDocument/2006/relationships" id="2147483648" r:id="R144f1f78c788401d"/>
+    <p:sldMasterId xmlns:r="http://schemas.openxmlformats.org/officeDocument/2006/relationships" id="2147483648" r:id="Rdda5193dfc324df3"/>
   </p:sldMasterIdLst>
   <p:notesMasterIdLst>
-    <p:notesMasterId xmlns:r="http://schemas.openxmlformats.org/officeDocument/2006/relationships" r:id="R860fe095ac264686"/>
+    <p:notesMasterId xmlns:r="http://schemas.openxmlformats.org/officeDocument/2006/relationships" r:id="R37eb6038115442a1"/>
   </p:notesMasterIdLst>
   <p:sldIdLst>
-    <p:sldId xmlns:r="http://schemas.openxmlformats.org/officeDocument/2006/relationships" id="256" r:id="Rde0c65906f734ef3"/>
-    <p:sldId xmlns:r="http://schemas.openxmlformats.org/officeDocument/2006/relationships" id="257" r:id="R6a704a15303e4478"/>
-    <p:sldId xmlns:r="http://schemas.openxmlformats.org/officeDocument/2006/relationships" id="258" r:id="R53ccebde457f4cd7"/>
-    <p:sldId xmlns:r="http://schemas.openxmlformats.org/officeDocument/2006/relationships" id="259" r:id="R1bdad1b0f8024dba"/>
-    <p:sldId xmlns:r="http://schemas.openxmlformats.org/officeDocument/2006/relationships" id="260" r:id="R110a8ad59cb340ad"/>
-    <p:sldId xmlns:r="http://schemas.openxmlformats.org/officeDocument/2006/relationships" id="261" r:id="Rd1c97762498a483f"/>
-    <p:sldId xmlns:r="http://schemas.openxmlformats.org/officeDocument/2006/relationships" id="262" r:id="Rd656b08c94344883"/>
-    <p:sldId xmlns:r="http://schemas.openxmlformats.org/officeDocument/2006/relationships" id="263" r:id="Rbdf76f6488aa45fb"/>
-    <p:sldId xmlns:r="http://schemas.openxmlformats.org/officeDocument/2006/relationships" id="264" r:id="R93bc3a7479cb4d39"/>
-    <p:sldId xmlns:r="http://schemas.openxmlformats.org/officeDocument/2006/relationships" id="265" r:id="R8547fbe9a9e541ac"/>
-    <p:sldId xmlns:r="http://schemas.openxmlformats.org/officeDocument/2006/relationships" id="266" r:id="R96d97f952f2d47ee"/>
-    <p:sldId xmlns:r="http://schemas.openxmlformats.org/officeDocument/2006/relationships" id="267" r:id="R9d65e744178f4352"/>
-    <p:sldId xmlns:r="http://schemas.openxmlformats.org/officeDocument/2006/relationships" id="268" r:id="Rc2370fdb4c224baa"/>
-    <p:sldId xmlns:r="http://schemas.openxmlformats.org/officeDocument/2006/relationships" id="269" r:id="Rc290a39926524213"/>
-    <p:sldId xmlns:r="http://schemas.openxmlformats.org/officeDocument/2006/relationships" id="270" r:id="R2a2fa15592924920"/>
-    <p:sldId xmlns:r="http://schemas.openxmlformats.org/officeDocument/2006/relationships" id="271" r:id="R435bbc522df14753"/>
-    <p:sldId xmlns:r="http://schemas.openxmlformats.org/officeDocument/2006/relationships" id="272" r:id="R41d86f2b52be4a64"/>
-    <p:sldId xmlns:r="http://schemas.openxmlformats.org/officeDocument/2006/relationships" id="273" r:id="R7946a1e69b3d4337"/>
-    <p:sldId xmlns:r="http://schemas.openxmlformats.org/officeDocument/2006/relationships" id="274" r:id="Re802b888201347a5"/>
+    <p:sldId xmlns:r="http://schemas.openxmlformats.org/officeDocument/2006/relationships" id="256" r:id="Rc25146cc6eb442a2"/>
+    <p:sldId xmlns:r="http://schemas.openxmlformats.org/officeDocument/2006/relationships" id="257" r:id="R15538f0cf57a4b66"/>
+    <p:sldId xmlns:r="http://schemas.openxmlformats.org/officeDocument/2006/relationships" id="258" r:id="Re263e97ab4784791"/>
+    <p:sldId xmlns:r="http://schemas.openxmlformats.org/officeDocument/2006/relationships" id="259" r:id="Rb3547d0e330146cf"/>
+    <p:sldId xmlns:r="http://schemas.openxmlformats.org/officeDocument/2006/relationships" id="260" r:id="R3c7e1a5386fc4355"/>
+    <p:sldId xmlns:r="http://schemas.openxmlformats.org/officeDocument/2006/relationships" id="261" r:id="R0197c1c2c115476c"/>
+    <p:sldId xmlns:r="http://schemas.openxmlformats.org/officeDocument/2006/relationships" id="262" r:id="R8c9f29d2fde44fd7"/>
+    <p:sldId xmlns:r="http://schemas.openxmlformats.org/officeDocument/2006/relationships" id="263" r:id="Re4f08d2b245a47de"/>
+    <p:sldId xmlns:r="http://schemas.openxmlformats.org/officeDocument/2006/relationships" id="264" r:id="R285262d6652a4d42"/>
+    <p:sldId xmlns:r="http://schemas.openxmlformats.org/officeDocument/2006/relationships" id="265" r:id="Re94726165b904c49"/>
+    <p:sldId xmlns:r="http://schemas.openxmlformats.org/officeDocument/2006/relationships" id="266" r:id="Rd84f07185ffa43ef"/>
+    <p:sldId xmlns:r="http://schemas.openxmlformats.org/officeDocument/2006/relationships" id="267" r:id="R913befc2fbde4312"/>
+    <p:sldId xmlns:r="http://schemas.openxmlformats.org/officeDocument/2006/relationships" id="268" r:id="Rbcf58e2c077f4607"/>
+    <p:sldId xmlns:r="http://schemas.openxmlformats.org/officeDocument/2006/relationships" id="269" r:id="R72fecdfbd5c8444f"/>
+    <p:sldId xmlns:r="http://schemas.openxmlformats.org/officeDocument/2006/relationships" id="270" r:id="R55fdbe15664d46cd"/>
+    <p:sldId xmlns:r="http://schemas.openxmlformats.org/officeDocument/2006/relationships" id="271" r:id="R4494d5d4bd16433f"/>
+    <p:sldId xmlns:r="http://schemas.openxmlformats.org/officeDocument/2006/relationships" id="272" r:id="Rc72c4a2f8b004403"/>
+    <p:sldId xmlns:r="http://schemas.openxmlformats.org/officeDocument/2006/relationships" id="273" r:id="R3f8bcc5bfaec472c"/>
+    <p:sldId xmlns:r="http://schemas.openxmlformats.org/officeDocument/2006/relationships" id="274" r:id="Rb4d8d8f5cad34e78"/>
   </p:sldIdLst>
   <p:sldSz cx="12192000" cy="6858000"/>
   <p:notesSz cx="6858000" cy="9144000"/>
@@ -1877,7 +1877,7 @@
   </p:cSld>
   <p:clrMap bg1="lt1" tx1="dk1" bg2="lt2" tx2="dk2" accent1="accent1" accent2="accent2" accent3="accent3" accent4="accent4" accent5="accent5" accent6="accent6" hlink="hlink" folHlink="folHlink"/>
   <p:sldLayoutIdLst>
-    <p:sldLayoutId xmlns:r="http://schemas.openxmlformats.org/officeDocument/2006/relationships" id="2147483649" r:id="R929c5e3c408f44ca"/>
+    <p:sldLayoutId xmlns:r="http://schemas.openxmlformats.org/officeDocument/2006/relationships" id="2147483649" r:id="R3de848a0770a4b0f"/>
   </p:sldLayoutIdLst>
   <p:hf sldNum="0" hdr="0" ftr="0" dt="0"/>
   <p:txStyles>
@@ -6592,7 +6592,7 @@
                 <a:ea typeface="IBM Plex Sans"/>
                 <a:cs typeface="IBM Plex Sans"/>
               </a:rPr>
-              <a:t>How the two local processes exchange data</a:t>
+              <a:t>How Ridgeback and Thor exchange inference data</a:t>
             </a:r>
             <a:endParaRPr sz="3080"/>
           </a:p>
@@ -6627,7 +6627,7 @@
         </p:spPr>
         <p:txBody>
           <a:bodyPr xmlns:a="http://schemas.openxmlformats.org/drawingml/2006/main">
-            <a:normAutofit fontScale="94974"/>
+            <a:normAutofit fontScale="100000"/>
           </a:bodyPr>
           <a:lstStyle xmlns:a="http://schemas.openxmlformats.org/drawingml/2006/main"/>
           <a:p xmlns:a="http://schemas.openxmlformats.org/drawingml/2006/main">
@@ -6654,7 +6654,7 @@
                 <a:ea typeface="IBM Plex Sans"/>
                 <a:cs typeface="IBM Plex Sans"/>
               </a:rPr>
-              <a:t>The system uses two local processes because ROS 2 Jazzy runs in Python 3.12, while OmTrackVLA and CUDA run in Python 3.9. The ROS node receives compressed colour images, depth, LiDAR, E-stop, and deadman messages, then sends the selected JPEG and the full prompt to the inference server through a length-prefixed JSON connection on 127.0.0.1:18765. On the server, target tracking runs at 3 Hz, Grounding DINO runs every eighth target frame while searching or recovering, and OmTrackVLA runs at up to 2 Hz only after the target is locked. The server returns the target state, annotated image, waypoint path, and fields that state whether the planner ran. The ROS node fuses the path with target geometry, applies the safety limits at 20 Hz, and publishes cmd_vel only when every gate passes.</a:t>
+              <a:t>The Ridgeback computer runs ROS 2 Jazzy in Python 3.12. It receives compressed colour images, depth, LiDAR, E-stop and deadman data. In the Thor split, the ROS bridge sends the selected JPEG and full prompt over the robot network to this project’s inference server at 192.168.131.51:18765. Thor runs target tracking near 3 Hz and the OmTrackVLA planner after target lock, capped at 2 Hz. It returns target state, annotated image, waypoint path and planner status. Ridgeback keeps depth fusion, the 20 Hz safety gate and cmd_vel. The normal launcher still uses local inference; the Thor launchers are separate, and remote arming needs an explicit second opt-in. The live Thor result remains dry-run only.</a:t>
             </a:r>
           </a:p>
         </p:txBody>
@@ -8590,7 +8590,7 @@
                 <a:ea typeface="IBM Plex Sans"/>
                 <a:cs typeface="IBM Plex Sans"/>
               </a:rPr>
-              <a:t>The local suite has 59 passing tests. A clean restarted run used 5,403 MiB of GPU memory and published the Target Tracker view at about 3.08 Hz. Two short offline comparisons reduced locked-frame median latency from 303.8–319.1 ms to 193.2–197.6 ms with shared CUDA vision preprocessing, while preserving target states and permitted-frame counts. Live latency distributions and sustained planner cadence are still unmeasured. In a blue-basket trial, the intended person was LOCKED for 15/15 initial samples, then LOST in 19 of the next 20 statuses before reacquisition. This does not establish reliable sustained following.</a:t>
+              <a:t>The local suite has 62 passing tests. In a live Thor dry-run with a blue-basket holder, 93 of 187 frames were LOCKED; target depth and trajectory were valid during lock. The planner updated 31 times across 30.241 seconds of lock, about 1.03 Hz against a 2 Hz cap. One stale camera response was rejected; the 20 Hz host safety timer reached a 55.006 ms maximum interval. The E-stop remained active and no physical motion was tested. On 90 fresh Ridgeback camera frames, Thor and RTX matched every target and trajectory decision. A matched live RTX timing baseline, sustained planner cadence and armable safety checks remain open. No speedup is claimed.</a:t>
             </a:r>
           </a:p>
         </p:txBody>
@@ -9698,7 +9698,7 @@
           <p:nvPr/>
         </p:nvPicPr>
         <p:blipFill>
-          <a:blip xmlns:r="http://schemas.openxmlformats.org/officeDocument/2006/relationships" xmlns:a="http://schemas.openxmlformats.org/drawingml/2006/main" r:embed="Rf4ad36fa25ca417d"/>
+          <a:blip xmlns:r="http://schemas.openxmlformats.org/officeDocument/2006/relationships" xmlns:a="http://schemas.openxmlformats.org/drawingml/2006/main" r:embed="Rc5c4af061132426e"/>
           <a:srcRect xmlns:a="http://schemas.openxmlformats.org/drawingml/2006/main" l="-1" t="0" r="-1" b="0"/>
           <a:stretch xmlns:a="http://schemas.openxmlformats.org/drawingml/2006/main"/>
         </p:blipFill>
@@ -9721,7 +9721,7 @@
           <p:nvPr/>
         </p:nvPicPr>
         <p:blipFill>
-          <a:blip xmlns:r="http://schemas.openxmlformats.org/officeDocument/2006/relationships" xmlns:a="http://schemas.openxmlformats.org/drawingml/2006/main" r:embed="Rc641e95e19874fc3"/>
+          <a:blip xmlns:r="http://schemas.openxmlformats.org/officeDocument/2006/relationships" xmlns:a="http://schemas.openxmlformats.org/drawingml/2006/main" r:embed="R4fab2fe858d049cc"/>
           <a:srcRect xmlns:a="http://schemas.openxmlformats.org/drawingml/2006/main" l="-2" t="0" r="-2" b="0"/>
           <a:stretch xmlns:a="http://schemas.openxmlformats.org/drawingml/2006/main"/>
         </p:blipFill>
@@ -9744,7 +9744,7 @@
           <p:nvPr/>
         </p:nvPicPr>
         <p:blipFill>
-          <a:blip xmlns:r="http://schemas.openxmlformats.org/officeDocument/2006/relationships" xmlns:a="http://schemas.openxmlformats.org/drawingml/2006/main" r:embed="R0bd5d6d733aa4e35"/>
+          <a:blip xmlns:r="http://schemas.openxmlformats.org/officeDocument/2006/relationships" xmlns:a="http://schemas.openxmlformats.org/drawingml/2006/main" r:embed="R05ecf0c758a84562"/>
           <a:srcRect xmlns:a="http://schemas.openxmlformats.org/drawingml/2006/main" l="-31" t="0" r="-31" b="0"/>
           <a:stretch xmlns:a="http://schemas.openxmlformats.org/drawingml/2006/main"/>
         </p:blipFill>
@@ -9767,7 +9767,7 @@
           <p:nvPr/>
         </p:nvPicPr>
         <p:blipFill>
-          <a:blip xmlns:r="http://schemas.openxmlformats.org/officeDocument/2006/relationships" xmlns:a="http://schemas.openxmlformats.org/drawingml/2006/main" r:embed="R86a79f405c124dd8"/>
+          <a:blip xmlns:r="http://schemas.openxmlformats.org/officeDocument/2006/relationships" xmlns:a="http://schemas.openxmlformats.org/drawingml/2006/main" r:embed="Rc48f4de725ce4463"/>
           <a:srcRect xmlns:a="http://schemas.openxmlformats.org/drawingml/2006/main" l="-31" t="0" r="-31" b="0"/>
           <a:stretch xmlns:a="http://schemas.openxmlformats.org/drawingml/2006/main"/>
         </p:blipFill>
@@ -9790,7 +9790,7 @@
           <p:nvPr/>
         </p:nvPicPr>
         <p:blipFill>
-          <a:blip xmlns:r="http://schemas.openxmlformats.org/officeDocument/2006/relationships" xmlns:a="http://schemas.openxmlformats.org/drawingml/2006/main" r:embed="Rfdb525e97a774698"/>
+          <a:blip xmlns:r="http://schemas.openxmlformats.org/officeDocument/2006/relationships" xmlns:a="http://schemas.openxmlformats.org/drawingml/2006/main" r:embed="Rb0ab6822c60041f5"/>
           <a:srcRect xmlns:a="http://schemas.openxmlformats.org/drawingml/2006/main" l="0" t="0" r="0" b="0"/>
           <a:stretch xmlns:a="http://schemas.openxmlformats.org/drawingml/2006/main"/>
         </p:blipFill>
@@ -9813,7 +9813,7 @@
           <p:nvPr/>
         </p:nvPicPr>
         <p:blipFill>
-          <a:blip xmlns:r="http://schemas.openxmlformats.org/officeDocument/2006/relationships" xmlns:a="http://schemas.openxmlformats.org/drawingml/2006/main" r:embed="R1eb8049e00f1483f"/>
+          <a:blip xmlns:r="http://schemas.openxmlformats.org/officeDocument/2006/relationships" xmlns:a="http://schemas.openxmlformats.org/drawingml/2006/main" r:embed="R2d9ea44ac49540b0"/>
           <a:srcRect xmlns:a="http://schemas.openxmlformats.org/drawingml/2006/main" l="-1" t="0" r="-1" b="0"/>
           <a:stretch xmlns:a="http://schemas.openxmlformats.org/drawingml/2006/main"/>
         </p:blipFill>
@@ -10018,7 +10018,7 @@
           <p:nvPr/>
         </p:nvPicPr>
         <p:blipFill>
-          <a:blip xmlns:r="http://schemas.openxmlformats.org/officeDocument/2006/relationships" xmlns:a="http://schemas.openxmlformats.org/drawingml/2006/main" r:embed="R2ae0595a8e254fc3"/>
+          <a:blip xmlns:r="http://schemas.openxmlformats.org/officeDocument/2006/relationships" xmlns:a="http://schemas.openxmlformats.org/drawingml/2006/main" r:embed="R5a0f30b9b4454fc7"/>
           <a:srcRect xmlns:a="http://schemas.openxmlformats.org/drawingml/2006/main" l="-109" t="0" r="-109" b="0"/>
           <a:stretch xmlns:a="http://schemas.openxmlformats.org/drawingml/2006/main"/>
         </p:blipFill>
@@ -10736,7 +10736,7 @@
           <p:nvPr/>
         </p:nvPicPr>
         <p:blipFill>
-          <a:blip xmlns:r="http://schemas.openxmlformats.org/officeDocument/2006/relationships" xmlns:a="http://schemas.openxmlformats.org/drawingml/2006/main" r:embed="Rfd758225240e4311"/>
+          <a:blip xmlns:r="http://schemas.openxmlformats.org/officeDocument/2006/relationships" xmlns:a="http://schemas.openxmlformats.org/drawingml/2006/main" r:embed="R4247d14d6efb44a4"/>
           <a:srcRect xmlns:a="http://schemas.openxmlformats.org/drawingml/2006/main" l="0" t="-20" r="0" b="-20"/>
           <a:stretch xmlns:a="http://schemas.openxmlformats.org/drawingml/2006/main"/>
         </p:blipFill>
@@ -11192,6 +11192,7 @@
           <a:lstStyle xmlns:a="http://schemas.openxmlformats.org/drawingml/2006/main"/>
           <a:p xmlns:a="http://schemas.openxmlformats.org/drawingml/2006/main">
             <a:pPr>
+              <a:buNone/>
               <a:defRPr sz="2850" b="1">
                 <a:solidFill>
                   <a:srgbClr val="273943"/>

</xml_diff>